<commit_message>
Reorganiza relatório, adiciona figs e aprendizado_curso
- Move relatorio_ic.tex/pdf, referencias.bib para relatorios/
- Adiciona \graphicspath{{../}} para compilação from relatorios/
- Adiciona figs/diagramas e figs/geradas (figuras do relatório)
- Adiciona relatorios/Relatório de Atividades de Bolsas.docx
- Adiciona notebooks/gerar_figuras_relatorio.py
- Adiciona aprendizado_curso/ (notebooks de estudo)
- Atualiza anotacoes/analise_cnn_bilstm_autoencoder_v4.md
- Atualiza slides/wind_turbine_anomaly_detection_fixed.pptx
- Remove arquivos raiz movidos para relatorios/

Co-Authored-By: Claude Sonnet 4.6 <noreply@anthropic.com>
</commit_message>
<xml_diff>
--- a/slides/wind_turbine_anomaly_detection_fixed.pptx
+++ b/slides/wind_turbine_anomaly_detection_fixed.pptx
@@ -23040,7 +23040,7 @@
                 <a:ea typeface="Calibri" pitchFamily="34" charset="-122"/>
                 <a:cs typeface="Calibri" pitchFamily="34" charset="-120"/>
               </a:rPr>
-              <a:t>238 physical sensors expand to 952 raw columns because angular measurements (degrees) are split into sin/cos pairs — preserving circular continuity where 359° ≈ 1°.</a:t>
+              <a:t>238 physical sensors x 4 statistics (avg, min, max, std) = 952 raw SCADA columns. Sin/cos encoding is applied as a separate preprocessing step for angular features — preserving circular continuity where 359 deg is close to 1 deg.</a:t>
             </a:r>
             <a:endParaRPr lang="en-US" sz="900" dirty="0"/>
           </a:p>
@@ -23519,7 +23519,7 @@
                           <a:ea typeface="Calibri" pitchFamily="34" charset="-122"/>
                           <a:cs typeface="Calibri" pitchFamily="34" charset="-120"/>
                         </a:rPr>
-                        <a:t>51</a:t>
+                        <a:t>27</a:t>
                       </a:r>
                       <a:endParaRPr lang="en-US" sz="900" dirty="0">
                         <a:latin typeface="Calibri" charset="0"/>
@@ -23721,7 +23721,7 @@
                           <a:ea typeface="Calibri" pitchFamily="34" charset="-122"/>
                           <a:cs typeface="Calibri" pitchFamily="34" charset="-120"/>
                         </a:rPr>
-                        <a:t>7</a:t>
+                        <a:t>31</a:t>
                       </a:r>
                       <a:endParaRPr lang="en-US" sz="900" dirty="0">
                         <a:latin typeface="Calibri" charset="0"/>

</xml_diff>